<commit_message>
Verify all 100 benchmark cases; fix rubrics and repair ground-truth decks
Full semantic verification of every case (deterministic audit + per-case
XML diff + rendered-slide review with adversarial confirmation):

- Correct style targets on 43 cases (plus prompts of cases 17 and 77) so
  the rubric accurately describes what the ground truth actually does
- Repair 14 defective ground-truth decks (cases 6, 7, 37, 45, 46, 50, 72,
  73, 75, 80, 83, 87, 97, 99): missed Q2 replacements, wrong transition
  family, corrupted dates, unalphabetized bibliography, overlapping or
  deleted chart labels, wrong duplicate slide removed, empty math objects,
  autoplaying video, fragmented SmartArt, wrong timeline layout and broken
  icons, and a full two-tone blue re-theme
- Every repaired deck re-verified against its rubric before commit
</commit_message>
<xml_diff>
--- a/GroundTruth/AddBibliography_GroundTruthA.pptx
+++ b/GroundTruth/AddBibliography_GroundTruthA.pptx
@@ -29715,15 +29715,15 @@
             </a:pPr>
             <a:r>
               <a:rPr lang="en-US" sz="1400" dirty="0"/>
-              <a:t>M. Ali and C. Mangione. Health Affairs, </a:t>
+              <a:t>Agarwal SD, Sommers BD. Insurance Coverage after Job Loss - The Importance of the ACA during the Covid-Associated Recession [published online ahead of print, 2020 Aug 19]. </a:t>
             </a:r>
             <a:r>
               <a:rPr lang="en-US" sz="1400" i="1" dirty="0"/>
-              <a:t>In Press, </a:t>
+              <a:t>N Engl J Med</a:t>
             </a:r>
             <a:r>
               <a:rPr lang="en-US" sz="1400" dirty="0"/>
-              <a:t>2020</a:t>
+              <a:t>. 2020;10.1056/NEJMp2023312. doi:10.1056/NEJMp2023312</a:t>
             </a:r>
           </a:p>
           <a:p>
@@ -29733,28 +29733,16 @@
               </a:lnSpc>
             </a:pPr>
             <a:r>
-              <a:rPr lang="en-US" sz="1400" dirty="0" err="1"/>
-              <a:t>Wosik</a:t>
-            </a:r>
-            <a:r>
               <a:rPr lang="en-US" sz="1400" dirty="0"/>
-              <a:t> J, et al. Telehealth transformation: COVID-19 and the rise of virtual care. </a:t>
+              <a:t>M. Ali and C. Mangione. Health Affairs, </a:t>
             </a:r>
             <a:r>
               <a:rPr lang="en-US" sz="1400" i="1" dirty="0"/>
-              <a:t>J Am Med Inform Assoc</a:t>
+              <a:t>In Press, </a:t>
             </a:r>
             <a:r>
               <a:rPr lang="en-US" sz="1400" dirty="0"/>
-              <a:t>. 2020;27(6):957-962. doi:10.1093/</a:t>
-            </a:r>
-            <a:r>
-              <a:rPr lang="en-US" sz="1400" dirty="0" err="1"/>
-              <a:t>jamia</a:t>
-            </a:r>
-            <a:r>
-              <a:rPr lang="en-US" sz="1400" dirty="0"/>
-              <a:t>/ocaa067</a:t>
+              <a:t>2020</a:t>
             </a:r>
           </a:p>
           <a:p>
@@ -29765,7 +29753,31 @@
             </a:pPr>
             <a:r>
               <a:rPr lang="en-US" sz="1400" dirty="0"/>
-              <a:t>Office of Health Informatics and Analytics, UCLA Health Information Technology</a:t>
+              <a:t>Garg S, et al. Hospitalization Rates and Characteristics of Patients Hospitalized with Laboratory-Confirmed Coronavirus Disease 2019 - COVID-NET, 14 States, March 1-30, 2020. </a:t>
+            </a:r>
+            <a:r>
+              <a:rPr lang="en-US" sz="1400" i="1" dirty="0"/>
+              <a:t>MMWR </a:t>
+            </a:r>
+            <a:r>
+              <a:rPr lang="en-US" sz="1400" i="1" dirty="0" err="1"/>
+              <a:t>Morb</a:t>
+            </a:r>
+            <a:r>
+              <a:rPr lang="en-US" sz="1400" i="1" dirty="0"/>
+              <a:t> Mortal </a:t>
+            </a:r>
+            <a:r>
+              <a:rPr lang="en-US" sz="1400" i="1" dirty="0" err="1"/>
+              <a:t>Wkly</a:t>
+            </a:r>
+            <a:r>
+              <a:rPr lang="en-US" sz="1400" i="1" dirty="0"/>
+              <a:t> Rep</a:t>
+            </a:r>
+            <a:r>
+              <a:rPr lang="en-US" sz="1400" dirty="0"/>
+              <a:t>. 2020;69(15):458-464. Published 2020 Apr 17. doi:10.15585/mmwr.mm6915e3</a:t>
             </a:r>
           </a:p>
           <a:p>
@@ -29776,15 +29788,7 @@
             </a:pPr>
             <a:r>
               <a:rPr lang="en-US" sz="1400" dirty="0"/>
-              <a:t>Richardson S, et al. Presenting Characteristics, Comorbidities, and Outcomes Among 5700 Patients Hospitalized With COVID-19 in the New York City Area. </a:t>
-            </a:r>
-            <a:r>
-              <a:rPr lang="en-US" sz="1400" i="1" dirty="0"/>
-              <a:t>JAMA.</a:t>
-            </a:r>
-            <a:r>
-              <a:rPr lang="en-US" sz="1400" dirty="0"/>
-              <a:t> 2020;323(20):2052–2059. doi:10.1001/jama.2020.6775</a:t>
+              <a:t>Office of Health Informatics and Analytics, UCLA Health Information Technology</a:t>
             </a:r>
           </a:p>
           <a:p>
@@ -29794,12 +29798,8 @@
               </a:lnSpc>
             </a:pPr>
             <a:r>
-              <a:rPr lang="en-US" sz="1400" dirty="0" err="1"/>
-              <a:t>Vahidy</a:t>
-            </a:r>
-            <a:r>
               <a:rPr lang="en-US" sz="1400" dirty="0"/>
-              <a:t> FS, et al. BMJ Open 2020;10:e039849. doi:10.1136/ bmjopen-2020-039849</a:t>
+              <a:t>Patrick SW, Henkhaus LE, Zickafoose JS, et al. Wellbeing of Parents and Children During the COVID-19 Pandemic: A National Survey. Pediatrics. 2020;146(4):e2020016824</a:t>
             </a:r>
           </a:p>
           <a:p>
@@ -29809,32 +29809,10 @@
               </a:lnSpc>
             </a:pPr>
             <a:r>
-              <a:rPr lang="en-US" sz="1400" dirty="0"/>
-              <a:t>Garg S, et al. Hospitalization Rates and Characteristics of Patients Hospitalized with Laboratory-Confirmed Coronavirus Disease 2019 - COVID-NET, 14 States, March 1-30, 2020. </a:t>
-            </a:r>
-            <a:r>
-              <a:rPr lang="en-US" sz="1400" i="1" dirty="0"/>
-              <a:t>MMWR </a:t>
-            </a:r>
-            <a:r>
-              <a:rPr lang="en-US" sz="1400" i="1" dirty="0" err="1"/>
-              <a:t>Morb</a:t>
-            </a:r>
-            <a:r>
-              <a:rPr lang="en-US" sz="1400" i="1" dirty="0"/>
-              <a:t> Mortal </a:t>
-            </a:r>
-            <a:r>
-              <a:rPr lang="en-US" sz="1400" i="1" dirty="0" err="1"/>
-              <a:t>Wkly</a:t>
-            </a:r>
-            <a:r>
-              <a:rPr lang="en-US" sz="1400" i="1" dirty="0"/>
-              <a:t> Rep</a:t>
-            </a:r>
-            <a:r>
-              <a:rPr lang="en-US" sz="1400" dirty="0"/>
-              <a:t>. 2020;69(15):458-464. Published 2020 Apr 17. doi:10.15585/mmwr.mm6915e3</a:t>
+              <a:rPr lang="en-GB" sz="1400" dirty="0">
+                <a:latin typeface="Arial" charset="0"/>
+              </a:rPr>
+              <a:t>Price-Haywood EG et al. N Engl J Med 2020;382:2534-2543</a:t>
             </a:r>
           </a:p>
           <a:p>
@@ -29845,21 +29823,15 @@
             </a:pPr>
             <a:r>
               <a:rPr lang="en-US" sz="1400" dirty="0"/>
-              <a:t>Agarwal SD, Sommers BD. Insurance Coverage after Job Loss - The Importance of the ACA during the Covid-Associated Recession [published online ahead of print, 2020 Aug 19]. </a:t>
+              <a:t>Richardson S, et al. Presenting Characteristics, Comorbidities, and Outcomes Among 5700 Patients Hospitalized With COVID-19 in the New York City Area. </a:t>
             </a:r>
             <a:r>
               <a:rPr lang="en-US" sz="1400" i="1" dirty="0"/>
-              <a:t>N Engl J Med</a:t>
+              <a:t>JAMA.</a:t>
             </a:r>
             <a:r>
               <a:rPr lang="en-US" sz="1400" dirty="0"/>
-              <a:t>. 2020;10.1056/NEJMp2023312. doi:10.1056/NEJMp2023312</a:t>
-            </a:r>
-            <a:r>
-              <a:rPr lang="en-GB" sz="1400" dirty="0">
-                <a:latin typeface="Arial" charset="0"/>
-              </a:rPr>
-              <a:t>Price-Haywood EG et al. N Engl J Med 2020;382:2534-2543</a:t>
+              <a:t> 2020;323(20):2052–2059. doi:10.1001/jama.2020.6775</a:t>
             </a:r>
           </a:p>
           <a:p>
@@ -29869,8 +29841,43 @@
               </a:lnSpc>
             </a:pPr>
             <a:r>
+              <a:rPr lang="en-US" sz="1400" dirty="0" err="1"/>
+              <a:t>Vahidy</a:t>
+            </a:r>
+            <a:r>
               <a:rPr lang="en-US" sz="1400" dirty="0"/>
-              <a:t>Patrick SW, Henkhaus LE, Zickafoose JS, et al. Wellbeing of Parents and Children During the COVID-19 Pandemic: A National Survey. Pediatrics. 2020;146(4):e2020016824</a:t>
+              <a:t> FS, et al. BMJ Open 2020;10:e039849. doi:10.1136/ bmjopen-2020-039849</a:t>
+            </a:r>
+          </a:p>
+          <a:p>
+            <a:pPr>
+              <a:lnSpc>
+                <a:spcPct val="100000"/>
+              </a:lnSpc>
+            </a:pPr>
+            <a:r>
+              <a:rPr lang="en-US" sz="1400" dirty="0" err="1"/>
+              <a:t>Wosik</a:t>
+            </a:r>
+            <a:r>
+              <a:rPr lang="en-US" sz="1400" dirty="0"/>
+              <a:t> J, et al. Telehealth transformation: COVID-19 and the rise of virtual care. </a:t>
+            </a:r>
+            <a:r>
+              <a:rPr lang="en-US" sz="1400" i="1" dirty="0"/>
+              <a:t>J Am Med Inform Assoc</a:t>
+            </a:r>
+            <a:r>
+              <a:rPr lang="en-US" sz="1400" dirty="0"/>
+              <a:t>. 2020;27(6):957-962. doi:10.1093/</a:t>
+            </a:r>
+            <a:r>
+              <a:rPr lang="en-US" sz="1400" dirty="0" err="1"/>
+              <a:t>jamia</a:t>
+            </a:r>
+            <a:r>
+              <a:rPr lang="en-US" sz="1400" dirty="0"/>
+              <a:t>/ocaa067</a:t>
             </a:r>
           </a:p>
           <a:p>

</xml_diff>